<commit_message>
Answer all seven of Eden's questions; fix mislabelled tipping points on slide 9
- briefing: Eden's exact wording, where the deck answers each question, and
  short answers to all seven; PDF rebuilt
- slide 9: switching cost 0.0057 and risk weight 7.5 / 14.9 are the balanced
  (Thomas) break-evens, not Lena's and Anna's; names removed, subtitle says so
- early internal notes marked as historical; decision log updated

Co-Authored-By: Claude Opus 5.5 <noreply@anthropic.com>
Claude-Session: https://claude.ai/code/session_01CcEajGATyXtAyeuxFLjPmw
</commit_message>
<xml_diff>
--- a/docs/deck/Quantum_Hackathon_28_10_updated.pptx
+++ b/docs/deck/Quantum_Hackathon_28_10_updated.pptx
@@ -15487,7 +15487,7 @@
                   <a:ea typeface="Calibri" panose="020F0502020204030204" pitchFamily="34" charset="-122"/>
                   <a:cs typeface="Palatino Linotype" panose="02040502050505030304" charset="0"/>
                 </a:rPr>
-                <a:t>Thomas: Tech edge −0.37 pts</a:t>
+                <a:t>Tech edge −0.37 pts</a:t>
               </a:r>
               <a:endParaRPr lang="en-US" altLang="zh-CN" sz="1800" b="1" dirty="0">
                 <a:solidFill>
@@ -15665,7 +15665,7 @@
                   <a:ea typeface="Calibri" panose="020F0502020204030204" pitchFamily="34" charset="-122"/>
                   <a:cs typeface="Palatino Linotype" panose="02040502050505030304" charset="0"/>
                 </a:rPr>
-                <a:t>Lena: </a:t>
+                <a:t/>
               </a:r>
               <a:r>
                 <a:rPr lang="en-US" sz="1800" b="1" dirty="0">
@@ -15816,7 +15816,7 @@
                 <a:ea typeface="Calibri" panose="020F0502020204030204" pitchFamily="34" charset="-122"/>
                 <a:cs typeface="Palatino Linotype" panose="02040502050505030304" charset="0"/>
               </a:rPr>
-              <a:t>Anna: </a:t>
+              <a:t/>
             </a:r>
             <a:r>
               <a:rPr lang="en-US" sz="1800" b="1" dirty="0">
@@ -16123,7 +16123,7 @@
                 <a:latin typeface="Palatino Linotype" panose="02040502050505030304" charset="0"/>
                 <a:cs typeface="Palatino Linotype" panose="02040502050505030304" charset="0"/>
               </a:rPr>
-              <a:t>Result 3 · tipping points from our sensitivity code</a:t>
+              <a:t>Result 3 · Thomas’s three tipping points, from our sensitivity code</a:t>
             </a:r>
             <a:endParaRPr lang="en-US" altLang="zh-CN" sz="1400" b="0" i="0">
               <a:solidFill>

</xml_diff>